<commit_message>
Apply WVU DSPIRA banners throughout the teaching collection
</commit_message>
<xml_diff>
--- a/assets/lessons/lectures/astronomy/time-and-planning-observations.pptx
+++ b/assets/lessons/lectures/astronomy/time-and-planning-observations.pptx
@@ -1699,67 +1699,6 @@
       </p:sp>
       <p:sp>
         <p:nvSpPr>
-          <p:cNvPr id="4" name="">
-            <a:extLst xmlns:a="http://schemas.openxmlformats.org/drawingml/2006/main">
-              <a:ext uri="{FF2B5EF4-FFF2-40B4-BE49-F238E27FC236}">
-                <a16:creationId xmlns:a16="http://schemas.microsoft.com/office/drawing/2014/main" id="{403D591D-945A-44C3-8732-263971710CAE}"/>
-              </a:ext>
-            </a:extLst>
-          </p:cNvPr>
-          <p:cNvSpPr>
-            <a:spLocks xmlns:a="http://schemas.openxmlformats.org/drawingml/2006/main" noGrp="1"/>
-          </p:cNvSpPr>
-          <p:nvPr/>
-        </p:nvSpPr>
-        <p:spPr>
-          <a:xfrm xmlns:a="http://schemas.openxmlformats.org/drawingml/2006/main">
-            <a:off x="228600" y="76200"/>
-            <a:ext cx="8686800" cy="228600"/>
-          </a:xfrm>
-          <a:prstGeom xmlns:a="http://schemas.openxmlformats.org/drawingml/2006/main" prst="rect">
-            <a:avLst/>
-          </a:prstGeom>
-          <a:noFill xmlns:a="http://schemas.openxmlformats.org/drawingml/2006/main"/>
-          <a:ln xmlns:a="http://schemas.openxmlformats.org/drawingml/2006/main" w="0">
-            <a:noFill/>
-          </a:ln>
-        </p:spPr>
-        <p:txBody>
-          <a:bodyPr xmlns:a="http://schemas.openxmlformats.org/drawingml/2006/main" wrap="none" lIns="0" tIns="0" rIns="0" bIns="0" anchor="t">
-            <a:noAutofit/>
-          </a:bodyPr>
-          <a:lstStyle xmlns:a="http://schemas.openxmlformats.org/drawingml/2006/main"/>
-          <a:p xmlns:a="http://schemas.openxmlformats.org/drawingml/2006/main">
-            <a:pPr>
-              <a:lnSpc>
-                <a:spcPct val="100000"/>
-              </a:lnSpc>
-              <a:buNone/>
-              <a:defRPr sz="1200" b="1" i="0">
-                <a:solidFill>
-                  <a:srgbClr val="002855"/>
-                </a:solidFill>
-                <a:latin typeface="Arial"/>
-                <a:ea typeface="Arial"/>
-                <a:cs typeface="Arial"/>
-              </a:defRPr>
-            </a:pPr>
-            <a:r>
-              <a:rPr sz="1200" b="1" i="0">
-                <a:solidFill>
-                  <a:srgbClr val="002855"/>
-                </a:solidFill>
-                <a:latin typeface="Arial"/>
-                <a:ea typeface="Arial"/>
-                <a:cs typeface="Arial"/>
-              </a:rPr>
-              <a:t>WVU DSPIRA</a:t>
-            </a:r>
-          </a:p>
-        </p:txBody>
-      </p:sp>
-      <p:sp>
-        <p:nvSpPr>
           <p:cNvPr id="5" name="">
             <a:extLst xmlns:a="http://schemas.openxmlformats.org/drawingml/2006/main">
               <a:ext uri="{FF2B5EF4-FFF2-40B4-BE49-F238E27FC236}">
@@ -1876,6 +1815,156 @@
                 <a:cs typeface="Arial"/>
               </a:rPr>
               <a:t>1 of 8</a:t>
+            </a:r>
+          </a:p>
+        </p:txBody>
+      </p:sp>
+      <p:sp>
+        <p:nvSpPr>
+          <p:cNvPr id="8" name="WVU DSPIRA navy band"/>
+          <p:cNvSpPr>
+            <a:spLocks xmlns:a="http://schemas.openxmlformats.org/drawingml/2006/main" noGrp="1"/>
+          </p:cNvSpPr>
+          <p:nvPr/>
+        </p:nvSpPr>
+        <p:spPr>
+          <a:xfrm xmlns:a="http://schemas.openxmlformats.org/drawingml/2006/main">
+            <a:off x="0" y="0"/>
+            <a:ext cx="9144000" cy="323850"/>
+          </a:xfrm>
+          <a:prstGeom xmlns:a="http://schemas.openxmlformats.org/drawingml/2006/main" prst="rect">
+            <a:avLst/>
+          </a:prstGeom>
+          <a:solidFill xmlns:a="http://schemas.openxmlformats.org/drawingml/2006/main">
+            <a:srgbClr val="002855"/>
+          </a:solidFill>
+          <a:ln xmlns:a="http://schemas.openxmlformats.org/drawingml/2006/main" w="0">
+            <a:noFill/>
+          </a:ln>
+        </p:spPr>
+      </p:sp>
+      <p:sp>
+        <p:nvSpPr>
+          <p:cNvPr id="9" name="WVU DSPIRA gold rule"/>
+          <p:cNvSpPr>
+            <a:spLocks xmlns:a="http://schemas.openxmlformats.org/drawingml/2006/main" noGrp="1"/>
+          </p:cNvSpPr>
+          <p:nvPr/>
+        </p:nvSpPr>
+        <p:spPr>
+          <a:xfrm xmlns:a="http://schemas.openxmlformats.org/drawingml/2006/main">
+            <a:off x="0" y="323850"/>
+            <a:ext cx="9144000" cy="19050"/>
+          </a:xfrm>
+          <a:prstGeom xmlns:a="http://schemas.openxmlformats.org/drawingml/2006/main" prst="rect">
+            <a:avLst/>
+          </a:prstGeom>
+          <a:solidFill xmlns:a="http://schemas.openxmlformats.org/drawingml/2006/main">
+            <a:srgbClr val="EEAA00"/>
+          </a:solidFill>
+          <a:ln xmlns:a="http://schemas.openxmlformats.org/drawingml/2006/main" w="0">
+            <a:noFill/>
+          </a:ln>
+        </p:spPr>
+      </p:sp>
+      <p:sp>
+        <p:nvSpPr>
+          <p:cNvPr id="10" name="WVU DSPIRA name"/>
+          <p:cNvSpPr>
+            <a:spLocks xmlns:a="http://schemas.openxmlformats.org/drawingml/2006/main" noGrp="1"/>
+          </p:cNvSpPr>
+          <p:nvPr/>
+        </p:nvSpPr>
+        <p:spPr>
+          <a:xfrm xmlns:a="http://schemas.openxmlformats.org/drawingml/2006/main">
+            <a:off x="228600" y="19050"/>
+            <a:ext cx="2857500" cy="257175"/>
+          </a:xfrm>
+          <a:prstGeom xmlns:a="http://schemas.openxmlformats.org/drawingml/2006/main" prst="rect">
+            <a:avLst/>
+          </a:prstGeom>
+          <a:noFill xmlns:a="http://schemas.openxmlformats.org/drawingml/2006/main"/>
+          <a:ln xmlns:a="http://schemas.openxmlformats.org/drawingml/2006/main" w="0">
+            <a:noFill/>
+          </a:ln>
+        </p:spPr>
+        <p:txBody>
+          <a:bodyPr xmlns:a="http://schemas.openxmlformats.org/drawingml/2006/main">
+            <a:noAutofit/>
+          </a:bodyPr>
+          <a:lstStyle xmlns:a="http://schemas.openxmlformats.org/drawingml/2006/main"/>
+          <a:p xmlns:a="http://schemas.openxmlformats.org/drawingml/2006/main">
+            <a:pPr>
+              <a:defRPr sz="1600" b="1">
+                <a:solidFill>
+                  <a:srgbClr val="FFFFFF"/>
+                </a:solidFill>
+                <a:latin typeface="Arial"/>
+                <a:ea typeface="Arial"/>
+                <a:cs typeface="Arial"/>
+              </a:defRPr>
+            </a:pPr>
+            <a:r>
+              <a:rPr sz="1600" b="1">
+                <a:solidFill>
+                  <a:srgbClr val="FFFFFF"/>
+                </a:solidFill>
+                <a:latin typeface="Arial"/>
+                <a:ea typeface="Arial"/>
+                <a:cs typeface="Arial"/>
+              </a:rPr>
+              <a:t>WVU DSPIRA</a:t>
+            </a:r>
+          </a:p>
+        </p:txBody>
+      </p:sp>
+      <p:sp>
+        <p:nvSpPr>
+          <p:cNvPr id="11" name="WVU DSPIRA university"/>
+          <p:cNvSpPr>
+            <a:spLocks xmlns:a="http://schemas.openxmlformats.org/drawingml/2006/main" noGrp="1"/>
+          </p:cNvSpPr>
+          <p:nvPr/>
+        </p:nvSpPr>
+        <p:spPr>
+          <a:xfrm xmlns:a="http://schemas.openxmlformats.org/drawingml/2006/main">
+            <a:off x="6286500" y="114300"/>
+            <a:ext cx="2628900" cy="171450"/>
+          </a:xfrm>
+          <a:prstGeom xmlns:a="http://schemas.openxmlformats.org/drawingml/2006/main" prst="rect">
+            <a:avLst/>
+          </a:prstGeom>
+          <a:noFill xmlns:a="http://schemas.openxmlformats.org/drawingml/2006/main"/>
+          <a:ln xmlns:a="http://schemas.openxmlformats.org/drawingml/2006/main" w="0">
+            <a:noFill/>
+          </a:ln>
+        </p:spPr>
+        <p:txBody>
+          <a:bodyPr xmlns:a="http://schemas.openxmlformats.org/drawingml/2006/main">
+            <a:noAutofit/>
+          </a:bodyPr>
+          <a:lstStyle xmlns:a="http://schemas.openxmlformats.org/drawingml/2006/main"/>
+          <a:p xmlns:a="http://schemas.openxmlformats.org/drawingml/2006/main">
+            <a:pPr algn="r">
+              <a:defRPr sz="900">
+                <a:solidFill>
+                  <a:srgbClr val="FFFFFF"/>
+                </a:solidFill>
+                <a:latin typeface="Arial"/>
+                <a:ea typeface="Arial"/>
+                <a:cs typeface="Arial"/>
+              </a:defRPr>
+            </a:pPr>
+            <a:r>
+              <a:rPr sz="900">
+                <a:solidFill>
+                  <a:srgbClr val="FFFFFF"/>
+                </a:solidFill>
+                <a:latin typeface="Arial"/>
+                <a:ea typeface="Arial"/>
+                <a:cs typeface="Arial"/>
+              </a:rPr>
+              <a:t>WEST VIRGINIA UNIVERSITY</a:t>
             </a:r>
           </a:p>
         </p:txBody>
@@ -1933,67 +2022,6 @@
       </p:pic>
       <p:sp>
         <p:nvSpPr>
-          <p:cNvPr id="2" name="">
-            <a:extLst xmlns:a="http://schemas.openxmlformats.org/drawingml/2006/main">
-              <a:ext uri="{FF2B5EF4-FFF2-40B4-BE49-F238E27FC236}">
-                <a16:creationId xmlns:a16="http://schemas.microsoft.com/office/drawing/2014/main" id="{EE95DAD3-B69B-4CC3-BF3F-96FE486933CC}"/>
-              </a:ext>
-            </a:extLst>
-          </p:cNvPr>
-          <p:cNvSpPr>
-            <a:spLocks xmlns:a="http://schemas.openxmlformats.org/drawingml/2006/main" noGrp="1"/>
-          </p:cNvSpPr>
-          <p:nvPr/>
-        </p:nvSpPr>
-        <p:spPr>
-          <a:xfrm xmlns:a="http://schemas.openxmlformats.org/drawingml/2006/main">
-            <a:off x="228600" y="76200"/>
-            <a:ext cx="8686800" cy="228600"/>
-          </a:xfrm>
-          <a:prstGeom xmlns:a="http://schemas.openxmlformats.org/drawingml/2006/main" prst="rect">
-            <a:avLst/>
-          </a:prstGeom>
-          <a:noFill xmlns:a="http://schemas.openxmlformats.org/drawingml/2006/main"/>
-          <a:ln xmlns:a="http://schemas.openxmlformats.org/drawingml/2006/main" w="0">
-            <a:noFill/>
-          </a:ln>
-        </p:spPr>
-        <p:txBody>
-          <a:bodyPr xmlns:a="http://schemas.openxmlformats.org/drawingml/2006/main" wrap="none" lIns="0" tIns="0" rIns="0" bIns="0" anchor="t">
-            <a:noAutofit/>
-          </a:bodyPr>
-          <a:lstStyle xmlns:a="http://schemas.openxmlformats.org/drawingml/2006/main"/>
-          <a:p xmlns:a="http://schemas.openxmlformats.org/drawingml/2006/main">
-            <a:pPr>
-              <a:lnSpc>
-                <a:spcPct val="100000"/>
-              </a:lnSpc>
-              <a:buNone/>
-              <a:defRPr sz="1200" b="1" i="0">
-                <a:solidFill>
-                  <a:srgbClr val="002855"/>
-                </a:solidFill>
-                <a:latin typeface="Arial"/>
-                <a:ea typeface="Arial"/>
-                <a:cs typeface="Arial"/>
-              </a:defRPr>
-            </a:pPr>
-            <a:r>
-              <a:rPr sz="1200" b="1" i="0">
-                <a:solidFill>
-                  <a:srgbClr val="002855"/>
-                </a:solidFill>
-                <a:latin typeface="Arial"/>
-                <a:ea typeface="Arial"/>
-                <a:cs typeface="Arial"/>
-              </a:rPr>
-              <a:t>WVU DSPIRA</a:t>
-            </a:r>
-          </a:p>
-        </p:txBody>
-      </p:sp>
-      <p:sp>
-        <p:nvSpPr>
           <p:cNvPr id="3" name="">
             <a:extLst xmlns:a="http://schemas.openxmlformats.org/drawingml/2006/main">
               <a:ext uri="{FF2B5EF4-FFF2-40B4-BE49-F238E27FC236}">
@@ -2110,6 +2138,156 @@
                 <a:cs typeface="Arial"/>
               </a:rPr>
               <a:t>2 of 8</a:t>
+            </a:r>
+          </a:p>
+        </p:txBody>
+      </p:sp>
+      <p:sp>
+        <p:nvSpPr>
+          <p:cNvPr id="6" name="WVU DSPIRA navy band"/>
+          <p:cNvSpPr>
+            <a:spLocks xmlns:a="http://schemas.openxmlformats.org/drawingml/2006/main" noGrp="1"/>
+          </p:cNvSpPr>
+          <p:nvPr/>
+        </p:nvSpPr>
+        <p:spPr>
+          <a:xfrm xmlns:a="http://schemas.openxmlformats.org/drawingml/2006/main">
+            <a:off x="0" y="0"/>
+            <a:ext cx="9144000" cy="323850"/>
+          </a:xfrm>
+          <a:prstGeom xmlns:a="http://schemas.openxmlformats.org/drawingml/2006/main" prst="rect">
+            <a:avLst/>
+          </a:prstGeom>
+          <a:solidFill xmlns:a="http://schemas.openxmlformats.org/drawingml/2006/main">
+            <a:srgbClr val="002855"/>
+          </a:solidFill>
+          <a:ln xmlns:a="http://schemas.openxmlformats.org/drawingml/2006/main" w="0">
+            <a:noFill/>
+          </a:ln>
+        </p:spPr>
+      </p:sp>
+      <p:sp>
+        <p:nvSpPr>
+          <p:cNvPr id="7" name="WVU DSPIRA gold rule"/>
+          <p:cNvSpPr>
+            <a:spLocks xmlns:a="http://schemas.openxmlformats.org/drawingml/2006/main" noGrp="1"/>
+          </p:cNvSpPr>
+          <p:nvPr/>
+        </p:nvSpPr>
+        <p:spPr>
+          <a:xfrm xmlns:a="http://schemas.openxmlformats.org/drawingml/2006/main">
+            <a:off x="0" y="323850"/>
+            <a:ext cx="9144000" cy="19050"/>
+          </a:xfrm>
+          <a:prstGeom xmlns:a="http://schemas.openxmlformats.org/drawingml/2006/main" prst="rect">
+            <a:avLst/>
+          </a:prstGeom>
+          <a:solidFill xmlns:a="http://schemas.openxmlformats.org/drawingml/2006/main">
+            <a:srgbClr val="EEAA00"/>
+          </a:solidFill>
+          <a:ln xmlns:a="http://schemas.openxmlformats.org/drawingml/2006/main" w="0">
+            <a:noFill/>
+          </a:ln>
+        </p:spPr>
+      </p:sp>
+      <p:sp>
+        <p:nvSpPr>
+          <p:cNvPr id="8" name="WVU DSPIRA name"/>
+          <p:cNvSpPr>
+            <a:spLocks xmlns:a="http://schemas.openxmlformats.org/drawingml/2006/main" noGrp="1"/>
+          </p:cNvSpPr>
+          <p:nvPr/>
+        </p:nvSpPr>
+        <p:spPr>
+          <a:xfrm xmlns:a="http://schemas.openxmlformats.org/drawingml/2006/main">
+            <a:off x="228600" y="19050"/>
+            <a:ext cx="2857500" cy="257175"/>
+          </a:xfrm>
+          <a:prstGeom xmlns:a="http://schemas.openxmlformats.org/drawingml/2006/main" prst="rect">
+            <a:avLst/>
+          </a:prstGeom>
+          <a:noFill xmlns:a="http://schemas.openxmlformats.org/drawingml/2006/main"/>
+          <a:ln xmlns:a="http://schemas.openxmlformats.org/drawingml/2006/main" w="0">
+            <a:noFill/>
+          </a:ln>
+        </p:spPr>
+        <p:txBody>
+          <a:bodyPr xmlns:a="http://schemas.openxmlformats.org/drawingml/2006/main">
+            <a:noAutofit/>
+          </a:bodyPr>
+          <a:lstStyle xmlns:a="http://schemas.openxmlformats.org/drawingml/2006/main"/>
+          <a:p xmlns:a="http://schemas.openxmlformats.org/drawingml/2006/main">
+            <a:pPr>
+              <a:defRPr sz="1600" b="1">
+                <a:solidFill>
+                  <a:srgbClr val="FFFFFF"/>
+                </a:solidFill>
+                <a:latin typeface="Arial"/>
+                <a:ea typeface="Arial"/>
+                <a:cs typeface="Arial"/>
+              </a:defRPr>
+            </a:pPr>
+            <a:r>
+              <a:rPr sz="1600" b="1">
+                <a:solidFill>
+                  <a:srgbClr val="FFFFFF"/>
+                </a:solidFill>
+                <a:latin typeface="Arial"/>
+                <a:ea typeface="Arial"/>
+                <a:cs typeface="Arial"/>
+              </a:rPr>
+              <a:t>WVU DSPIRA</a:t>
+            </a:r>
+          </a:p>
+        </p:txBody>
+      </p:sp>
+      <p:sp>
+        <p:nvSpPr>
+          <p:cNvPr id="9" name="WVU DSPIRA university"/>
+          <p:cNvSpPr>
+            <a:spLocks xmlns:a="http://schemas.openxmlformats.org/drawingml/2006/main" noGrp="1"/>
+          </p:cNvSpPr>
+          <p:nvPr/>
+        </p:nvSpPr>
+        <p:spPr>
+          <a:xfrm xmlns:a="http://schemas.openxmlformats.org/drawingml/2006/main">
+            <a:off x="6286500" y="114300"/>
+            <a:ext cx="2628900" cy="171450"/>
+          </a:xfrm>
+          <a:prstGeom xmlns:a="http://schemas.openxmlformats.org/drawingml/2006/main" prst="rect">
+            <a:avLst/>
+          </a:prstGeom>
+          <a:noFill xmlns:a="http://schemas.openxmlformats.org/drawingml/2006/main"/>
+          <a:ln xmlns:a="http://schemas.openxmlformats.org/drawingml/2006/main" w="0">
+            <a:noFill/>
+          </a:ln>
+        </p:spPr>
+        <p:txBody>
+          <a:bodyPr xmlns:a="http://schemas.openxmlformats.org/drawingml/2006/main">
+            <a:noAutofit/>
+          </a:bodyPr>
+          <a:lstStyle xmlns:a="http://schemas.openxmlformats.org/drawingml/2006/main"/>
+          <a:p xmlns:a="http://schemas.openxmlformats.org/drawingml/2006/main">
+            <a:pPr algn="r">
+              <a:defRPr sz="900">
+                <a:solidFill>
+                  <a:srgbClr val="FFFFFF"/>
+                </a:solidFill>
+                <a:latin typeface="Arial"/>
+                <a:ea typeface="Arial"/>
+                <a:cs typeface="Arial"/>
+              </a:defRPr>
+            </a:pPr>
+            <a:r>
+              <a:rPr sz="900">
+                <a:solidFill>
+                  <a:srgbClr val="FFFFFF"/>
+                </a:solidFill>
+                <a:latin typeface="Arial"/>
+                <a:ea typeface="Arial"/>
+                <a:cs typeface="Arial"/>
+              </a:rPr>
+              <a:t>WEST VIRGINIA UNIVERSITY</a:t>
             </a:r>
           </a:p>
         </p:txBody>
@@ -2411,67 +2589,6 @@
       </p:sp>
       <p:sp>
         <p:nvSpPr>
-          <p:cNvPr id="6" name="">
-            <a:extLst xmlns:a="http://schemas.openxmlformats.org/drawingml/2006/main">
-              <a:ext uri="{FF2B5EF4-FFF2-40B4-BE49-F238E27FC236}">
-                <a16:creationId xmlns:a16="http://schemas.microsoft.com/office/drawing/2014/main" id="{1934BA64-DA7B-4059-8A17-567A9DE739E2}"/>
-              </a:ext>
-            </a:extLst>
-          </p:cNvPr>
-          <p:cNvSpPr>
-            <a:spLocks xmlns:a="http://schemas.openxmlformats.org/drawingml/2006/main" noGrp="1"/>
-          </p:cNvSpPr>
-          <p:nvPr/>
-        </p:nvSpPr>
-        <p:spPr>
-          <a:xfrm xmlns:a="http://schemas.openxmlformats.org/drawingml/2006/main">
-            <a:off x="228600" y="76200"/>
-            <a:ext cx="8686800" cy="228600"/>
-          </a:xfrm>
-          <a:prstGeom xmlns:a="http://schemas.openxmlformats.org/drawingml/2006/main" prst="rect">
-            <a:avLst/>
-          </a:prstGeom>
-          <a:noFill xmlns:a="http://schemas.openxmlformats.org/drawingml/2006/main"/>
-          <a:ln xmlns:a="http://schemas.openxmlformats.org/drawingml/2006/main" w="0">
-            <a:noFill/>
-          </a:ln>
-        </p:spPr>
-        <p:txBody>
-          <a:bodyPr xmlns:a="http://schemas.openxmlformats.org/drawingml/2006/main" wrap="none" lIns="0" tIns="0" rIns="0" bIns="0" anchor="t">
-            <a:noAutofit/>
-          </a:bodyPr>
-          <a:lstStyle xmlns:a="http://schemas.openxmlformats.org/drawingml/2006/main"/>
-          <a:p xmlns:a="http://schemas.openxmlformats.org/drawingml/2006/main">
-            <a:pPr>
-              <a:lnSpc>
-                <a:spcPct val="100000"/>
-              </a:lnSpc>
-              <a:buNone/>
-              <a:defRPr sz="1200" b="1" i="0">
-                <a:solidFill>
-                  <a:srgbClr val="002855"/>
-                </a:solidFill>
-                <a:latin typeface="Arial"/>
-                <a:ea typeface="Arial"/>
-                <a:cs typeface="Arial"/>
-              </a:defRPr>
-            </a:pPr>
-            <a:r>
-              <a:rPr sz="1200" b="1" i="0">
-                <a:solidFill>
-                  <a:srgbClr val="002855"/>
-                </a:solidFill>
-                <a:latin typeface="Arial"/>
-                <a:ea typeface="Arial"/>
-                <a:cs typeface="Arial"/>
-              </a:rPr>
-              <a:t>WVU DSPIRA</a:t>
-            </a:r>
-          </a:p>
-        </p:txBody>
-      </p:sp>
-      <p:sp>
-        <p:nvSpPr>
           <p:cNvPr id="7" name="">
             <a:extLst xmlns:a="http://schemas.openxmlformats.org/drawingml/2006/main">
               <a:ext uri="{FF2B5EF4-FFF2-40B4-BE49-F238E27FC236}">
@@ -2588,6 +2705,156 @@
                 <a:cs typeface="Arial"/>
               </a:rPr>
               <a:t>3 of 8</a:t>
+            </a:r>
+          </a:p>
+        </p:txBody>
+      </p:sp>
+      <p:sp>
+        <p:nvSpPr>
+          <p:cNvPr id="10" name="WVU DSPIRA navy band"/>
+          <p:cNvSpPr>
+            <a:spLocks xmlns:a="http://schemas.openxmlformats.org/drawingml/2006/main" noGrp="1"/>
+          </p:cNvSpPr>
+          <p:nvPr/>
+        </p:nvSpPr>
+        <p:spPr>
+          <a:xfrm xmlns:a="http://schemas.openxmlformats.org/drawingml/2006/main">
+            <a:off x="0" y="0"/>
+            <a:ext cx="9144000" cy="323850"/>
+          </a:xfrm>
+          <a:prstGeom xmlns:a="http://schemas.openxmlformats.org/drawingml/2006/main" prst="rect">
+            <a:avLst/>
+          </a:prstGeom>
+          <a:solidFill xmlns:a="http://schemas.openxmlformats.org/drawingml/2006/main">
+            <a:srgbClr val="002855"/>
+          </a:solidFill>
+          <a:ln xmlns:a="http://schemas.openxmlformats.org/drawingml/2006/main" w="0">
+            <a:noFill/>
+          </a:ln>
+        </p:spPr>
+      </p:sp>
+      <p:sp>
+        <p:nvSpPr>
+          <p:cNvPr id="11" name="WVU DSPIRA gold rule"/>
+          <p:cNvSpPr>
+            <a:spLocks xmlns:a="http://schemas.openxmlformats.org/drawingml/2006/main" noGrp="1"/>
+          </p:cNvSpPr>
+          <p:nvPr/>
+        </p:nvSpPr>
+        <p:spPr>
+          <a:xfrm xmlns:a="http://schemas.openxmlformats.org/drawingml/2006/main">
+            <a:off x="0" y="323850"/>
+            <a:ext cx="9144000" cy="19050"/>
+          </a:xfrm>
+          <a:prstGeom xmlns:a="http://schemas.openxmlformats.org/drawingml/2006/main" prst="rect">
+            <a:avLst/>
+          </a:prstGeom>
+          <a:solidFill xmlns:a="http://schemas.openxmlformats.org/drawingml/2006/main">
+            <a:srgbClr val="EEAA00"/>
+          </a:solidFill>
+          <a:ln xmlns:a="http://schemas.openxmlformats.org/drawingml/2006/main" w="0">
+            <a:noFill/>
+          </a:ln>
+        </p:spPr>
+      </p:sp>
+      <p:sp>
+        <p:nvSpPr>
+          <p:cNvPr id="12" name="WVU DSPIRA name"/>
+          <p:cNvSpPr>
+            <a:spLocks xmlns:a="http://schemas.openxmlformats.org/drawingml/2006/main" noGrp="1"/>
+          </p:cNvSpPr>
+          <p:nvPr/>
+        </p:nvSpPr>
+        <p:spPr>
+          <a:xfrm xmlns:a="http://schemas.openxmlformats.org/drawingml/2006/main">
+            <a:off x="228600" y="19050"/>
+            <a:ext cx="2857500" cy="257175"/>
+          </a:xfrm>
+          <a:prstGeom xmlns:a="http://schemas.openxmlformats.org/drawingml/2006/main" prst="rect">
+            <a:avLst/>
+          </a:prstGeom>
+          <a:noFill xmlns:a="http://schemas.openxmlformats.org/drawingml/2006/main"/>
+          <a:ln xmlns:a="http://schemas.openxmlformats.org/drawingml/2006/main" w="0">
+            <a:noFill/>
+          </a:ln>
+        </p:spPr>
+        <p:txBody>
+          <a:bodyPr xmlns:a="http://schemas.openxmlformats.org/drawingml/2006/main">
+            <a:noAutofit/>
+          </a:bodyPr>
+          <a:lstStyle xmlns:a="http://schemas.openxmlformats.org/drawingml/2006/main"/>
+          <a:p xmlns:a="http://schemas.openxmlformats.org/drawingml/2006/main">
+            <a:pPr>
+              <a:defRPr sz="1600" b="1">
+                <a:solidFill>
+                  <a:srgbClr val="FFFFFF"/>
+                </a:solidFill>
+                <a:latin typeface="Arial"/>
+                <a:ea typeface="Arial"/>
+                <a:cs typeface="Arial"/>
+              </a:defRPr>
+            </a:pPr>
+            <a:r>
+              <a:rPr sz="1600" b="1">
+                <a:solidFill>
+                  <a:srgbClr val="FFFFFF"/>
+                </a:solidFill>
+                <a:latin typeface="Arial"/>
+                <a:ea typeface="Arial"/>
+                <a:cs typeface="Arial"/>
+              </a:rPr>
+              <a:t>WVU DSPIRA</a:t>
+            </a:r>
+          </a:p>
+        </p:txBody>
+      </p:sp>
+      <p:sp>
+        <p:nvSpPr>
+          <p:cNvPr id="13" name="WVU DSPIRA university"/>
+          <p:cNvSpPr>
+            <a:spLocks xmlns:a="http://schemas.openxmlformats.org/drawingml/2006/main" noGrp="1"/>
+          </p:cNvSpPr>
+          <p:nvPr/>
+        </p:nvSpPr>
+        <p:spPr>
+          <a:xfrm xmlns:a="http://schemas.openxmlformats.org/drawingml/2006/main">
+            <a:off x="6286500" y="114300"/>
+            <a:ext cx="2628900" cy="171450"/>
+          </a:xfrm>
+          <a:prstGeom xmlns:a="http://schemas.openxmlformats.org/drawingml/2006/main" prst="rect">
+            <a:avLst/>
+          </a:prstGeom>
+          <a:noFill xmlns:a="http://schemas.openxmlformats.org/drawingml/2006/main"/>
+          <a:ln xmlns:a="http://schemas.openxmlformats.org/drawingml/2006/main" w="0">
+            <a:noFill/>
+          </a:ln>
+        </p:spPr>
+        <p:txBody>
+          <a:bodyPr xmlns:a="http://schemas.openxmlformats.org/drawingml/2006/main">
+            <a:noAutofit/>
+          </a:bodyPr>
+          <a:lstStyle xmlns:a="http://schemas.openxmlformats.org/drawingml/2006/main"/>
+          <a:p xmlns:a="http://schemas.openxmlformats.org/drawingml/2006/main">
+            <a:pPr algn="r">
+              <a:defRPr sz="900">
+                <a:solidFill>
+                  <a:srgbClr val="FFFFFF"/>
+                </a:solidFill>
+                <a:latin typeface="Arial"/>
+                <a:ea typeface="Arial"/>
+                <a:cs typeface="Arial"/>
+              </a:defRPr>
+            </a:pPr>
+            <a:r>
+              <a:rPr sz="900">
+                <a:solidFill>
+                  <a:srgbClr val="FFFFFF"/>
+                </a:solidFill>
+                <a:latin typeface="Arial"/>
+                <a:ea typeface="Arial"/>
+                <a:cs typeface="Arial"/>
+              </a:rPr>
+              <a:t>WEST VIRGINIA UNIVERSITY</a:t>
             </a:r>
           </a:p>
         </p:txBody>
@@ -3621,67 +3888,6 @@
       </p:sp>
       <p:sp>
         <p:nvSpPr>
-          <p:cNvPr id="18" name="">
-            <a:extLst xmlns:a="http://schemas.openxmlformats.org/drawingml/2006/main">
-              <a:ext uri="{FF2B5EF4-FFF2-40B4-BE49-F238E27FC236}">
-                <a16:creationId xmlns:a16="http://schemas.microsoft.com/office/drawing/2014/main" id="{679E4776-1A28-4447-9989-8B48BE55E992}"/>
-              </a:ext>
-            </a:extLst>
-          </p:cNvPr>
-          <p:cNvSpPr>
-            <a:spLocks xmlns:a="http://schemas.openxmlformats.org/drawingml/2006/main" noGrp="1"/>
-          </p:cNvSpPr>
-          <p:nvPr/>
-        </p:nvSpPr>
-        <p:spPr>
-          <a:xfrm xmlns:a="http://schemas.openxmlformats.org/drawingml/2006/main">
-            <a:off x="228600" y="76200"/>
-            <a:ext cx="8686800" cy="228600"/>
-          </a:xfrm>
-          <a:prstGeom xmlns:a="http://schemas.openxmlformats.org/drawingml/2006/main" prst="rect">
-            <a:avLst/>
-          </a:prstGeom>
-          <a:noFill xmlns:a="http://schemas.openxmlformats.org/drawingml/2006/main"/>
-          <a:ln xmlns:a="http://schemas.openxmlformats.org/drawingml/2006/main" w="0">
-            <a:noFill/>
-          </a:ln>
-        </p:spPr>
-        <p:txBody>
-          <a:bodyPr xmlns:a="http://schemas.openxmlformats.org/drawingml/2006/main" wrap="none" lIns="0" tIns="0" rIns="0" bIns="0" anchor="t">
-            <a:noAutofit/>
-          </a:bodyPr>
-          <a:lstStyle xmlns:a="http://schemas.openxmlformats.org/drawingml/2006/main"/>
-          <a:p xmlns:a="http://schemas.openxmlformats.org/drawingml/2006/main">
-            <a:pPr>
-              <a:lnSpc>
-                <a:spcPct val="100000"/>
-              </a:lnSpc>
-              <a:buNone/>
-              <a:defRPr sz="1200" b="1" i="0">
-                <a:solidFill>
-                  <a:srgbClr val="002855"/>
-                </a:solidFill>
-                <a:latin typeface="Arial"/>
-                <a:ea typeface="Arial"/>
-                <a:cs typeface="Arial"/>
-              </a:defRPr>
-            </a:pPr>
-            <a:r>
-              <a:rPr sz="1200" b="1" i="0">
-                <a:solidFill>
-                  <a:srgbClr val="002855"/>
-                </a:solidFill>
-                <a:latin typeface="Arial"/>
-                <a:ea typeface="Arial"/>
-                <a:cs typeface="Arial"/>
-              </a:rPr>
-              <a:t>WVU DSPIRA</a:t>
-            </a:r>
-          </a:p>
-        </p:txBody>
-      </p:sp>
-      <p:sp>
-        <p:nvSpPr>
           <p:cNvPr id="19" name="">
             <a:extLst xmlns:a="http://schemas.openxmlformats.org/drawingml/2006/main">
               <a:ext uri="{FF2B5EF4-FFF2-40B4-BE49-F238E27FC236}">
@@ -3798,6 +4004,156 @@
                 <a:cs typeface="Arial"/>
               </a:rPr>
               <a:t>4 of 8</a:t>
+            </a:r>
+          </a:p>
+        </p:txBody>
+      </p:sp>
+      <p:sp>
+        <p:nvSpPr>
+          <p:cNvPr id="22" name="WVU DSPIRA navy band"/>
+          <p:cNvSpPr>
+            <a:spLocks xmlns:a="http://schemas.openxmlformats.org/drawingml/2006/main" noGrp="1"/>
+          </p:cNvSpPr>
+          <p:nvPr/>
+        </p:nvSpPr>
+        <p:spPr>
+          <a:xfrm xmlns:a="http://schemas.openxmlformats.org/drawingml/2006/main">
+            <a:off x="0" y="0"/>
+            <a:ext cx="9144000" cy="323850"/>
+          </a:xfrm>
+          <a:prstGeom xmlns:a="http://schemas.openxmlformats.org/drawingml/2006/main" prst="rect">
+            <a:avLst/>
+          </a:prstGeom>
+          <a:solidFill xmlns:a="http://schemas.openxmlformats.org/drawingml/2006/main">
+            <a:srgbClr val="002855"/>
+          </a:solidFill>
+          <a:ln xmlns:a="http://schemas.openxmlformats.org/drawingml/2006/main" w="0">
+            <a:noFill/>
+          </a:ln>
+        </p:spPr>
+      </p:sp>
+      <p:sp>
+        <p:nvSpPr>
+          <p:cNvPr id="23" name="WVU DSPIRA gold rule"/>
+          <p:cNvSpPr>
+            <a:spLocks xmlns:a="http://schemas.openxmlformats.org/drawingml/2006/main" noGrp="1"/>
+          </p:cNvSpPr>
+          <p:nvPr/>
+        </p:nvSpPr>
+        <p:spPr>
+          <a:xfrm xmlns:a="http://schemas.openxmlformats.org/drawingml/2006/main">
+            <a:off x="0" y="323850"/>
+            <a:ext cx="9144000" cy="19050"/>
+          </a:xfrm>
+          <a:prstGeom xmlns:a="http://schemas.openxmlformats.org/drawingml/2006/main" prst="rect">
+            <a:avLst/>
+          </a:prstGeom>
+          <a:solidFill xmlns:a="http://schemas.openxmlformats.org/drawingml/2006/main">
+            <a:srgbClr val="EEAA00"/>
+          </a:solidFill>
+          <a:ln xmlns:a="http://schemas.openxmlformats.org/drawingml/2006/main" w="0">
+            <a:noFill/>
+          </a:ln>
+        </p:spPr>
+      </p:sp>
+      <p:sp>
+        <p:nvSpPr>
+          <p:cNvPr id="24" name="WVU DSPIRA name"/>
+          <p:cNvSpPr>
+            <a:spLocks xmlns:a="http://schemas.openxmlformats.org/drawingml/2006/main" noGrp="1"/>
+          </p:cNvSpPr>
+          <p:nvPr/>
+        </p:nvSpPr>
+        <p:spPr>
+          <a:xfrm xmlns:a="http://schemas.openxmlformats.org/drawingml/2006/main">
+            <a:off x="228600" y="19050"/>
+            <a:ext cx="2857500" cy="257175"/>
+          </a:xfrm>
+          <a:prstGeom xmlns:a="http://schemas.openxmlformats.org/drawingml/2006/main" prst="rect">
+            <a:avLst/>
+          </a:prstGeom>
+          <a:noFill xmlns:a="http://schemas.openxmlformats.org/drawingml/2006/main"/>
+          <a:ln xmlns:a="http://schemas.openxmlformats.org/drawingml/2006/main" w="0">
+            <a:noFill/>
+          </a:ln>
+        </p:spPr>
+        <p:txBody>
+          <a:bodyPr xmlns:a="http://schemas.openxmlformats.org/drawingml/2006/main">
+            <a:noAutofit/>
+          </a:bodyPr>
+          <a:lstStyle xmlns:a="http://schemas.openxmlformats.org/drawingml/2006/main"/>
+          <a:p xmlns:a="http://schemas.openxmlformats.org/drawingml/2006/main">
+            <a:pPr>
+              <a:defRPr sz="1600" b="1">
+                <a:solidFill>
+                  <a:srgbClr val="FFFFFF"/>
+                </a:solidFill>
+                <a:latin typeface="Arial"/>
+                <a:ea typeface="Arial"/>
+                <a:cs typeface="Arial"/>
+              </a:defRPr>
+            </a:pPr>
+            <a:r>
+              <a:rPr sz="1600" b="1">
+                <a:solidFill>
+                  <a:srgbClr val="FFFFFF"/>
+                </a:solidFill>
+                <a:latin typeface="Arial"/>
+                <a:ea typeface="Arial"/>
+                <a:cs typeface="Arial"/>
+              </a:rPr>
+              <a:t>WVU DSPIRA</a:t>
+            </a:r>
+          </a:p>
+        </p:txBody>
+      </p:sp>
+      <p:sp>
+        <p:nvSpPr>
+          <p:cNvPr id="25" name="WVU DSPIRA university"/>
+          <p:cNvSpPr>
+            <a:spLocks xmlns:a="http://schemas.openxmlformats.org/drawingml/2006/main" noGrp="1"/>
+          </p:cNvSpPr>
+          <p:nvPr/>
+        </p:nvSpPr>
+        <p:spPr>
+          <a:xfrm xmlns:a="http://schemas.openxmlformats.org/drawingml/2006/main">
+            <a:off x="6286500" y="114300"/>
+            <a:ext cx="2628900" cy="171450"/>
+          </a:xfrm>
+          <a:prstGeom xmlns:a="http://schemas.openxmlformats.org/drawingml/2006/main" prst="rect">
+            <a:avLst/>
+          </a:prstGeom>
+          <a:noFill xmlns:a="http://schemas.openxmlformats.org/drawingml/2006/main"/>
+          <a:ln xmlns:a="http://schemas.openxmlformats.org/drawingml/2006/main" w="0">
+            <a:noFill/>
+          </a:ln>
+        </p:spPr>
+        <p:txBody>
+          <a:bodyPr xmlns:a="http://schemas.openxmlformats.org/drawingml/2006/main">
+            <a:noAutofit/>
+          </a:bodyPr>
+          <a:lstStyle xmlns:a="http://schemas.openxmlformats.org/drawingml/2006/main"/>
+          <a:p xmlns:a="http://schemas.openxmlformats.org/drawingml/2006/main">
+            <a:pPr algn="r">
+              <a:defRPr sz="900">
+                <a:solidFill>
+                  <a:srgbClr val="FFFFFF"/>
+                </a:solidFill>
+                <a:latin typeface="Arial"/>
+                <a:ea typeface="Arial"/>
+                <a:cs typeface="Arial"/>
+              </a:defRPr>
+            </a:pPr>
+            <a:r>
+              <a:rPr sz="900">
+                <a:solidFill>
+                  <a:srgbClr val="FFFFFF"/>
+                </a:solidFill>
+                <a:latin typeface="Arial"/>
+                <a:ea typeface="Arial"/>
+                <a:cs typeface="Arial"/>
+              </a:rPr>
+              <a:t>WEST VIRGINIA UNIVERSITY</a:t>
             </a:r>
           </a:p>
         </p:txBody>
@@ -4099,67 +4455,6 @@
       </p:sp>
       <p:sp>
         <p:nvSpPr>
-          <p:cNvPr id="6" name="">
-            <a:extLst xmlns:a="http://schemas.openxmlformats.org/drawingml/2006/main">
-              <a:ext uri="{FF2B5EF4-FFF2-40B4-BE49-F238E27FC236}">
-                <a16:creationId xmlns:a16="http://schemas.microsoft.com/office/drawing/2014/main" id="{7F76E884-96A0-45A0-ACAA-B65EAEC98C22}"/>
-              </a:ext>
-            </a:extLst>
-          </p:cNvPr>
-          <p:cNvSpPr>
-            <a:spLocks xmlns:a="http://schemas.openxmlformats.org/drawingml/2006/main" noGrp="1"/>
-          </p:cNvSpPr>
-          <p:nvPr/>
-        </p:nvSpPr>
-        <p:spPr>
-          <a:xfrm xmlns:a="http://schemas.openxmlformats.org/drawingml/2006/main">
-            <a:off x="228600" y="76200"/>
-            <a:ext cx="8686800" cy="228600"/>
-          </a:xfrm>
-          <a:prstGeom xmlns:a="http://schemas.openxmlformats.org/drawingml/2006/main" prst="rect">
-            <a:avLst/>
-          </a:prstGeom>
-          <a:noFill xmlns:a="http://schemas.openxmlformats.org/drawingml/2006/main"/>
-          <a:ln xmlns:a="http://schemas.openxmlformats.org/drawingml/2006/main" w="0">
-            <a:noFill/>
-          </a:ln>
-        </p:spPr>
-        <p:txBody>
-          <a:bodyPr xmlns:a="http://schemas.openxmlformats.org/drawingml/2006/main" wrap="none" lIns="0" tIns="0" rIns="0" bIns="0" anchor="t">
-            <a:noAutofit/>
-          </a:bodyPr>
-          <a:lstStyle xmlns:a="http://schemas.openxmlformats.org/drawingml/2006/main"/>
-          <a:p xmlns:a="http://schemas.openxmlformats.org/drawingml/2006/main">
-            <a:pPr>
-              <a:lnSpc>
-                <a:spcPct val="100000"/>
-              </a:lnSpc>
-              <a:buNone/>
-              <a:defRPr sz="1200" b="1" i="0">
-                <a:solidFill>
-                  <a:srgbClr val="002855"/>
-                </a:solidFill>
-                <a:latin typeface="Arial"/>
-                <a:ea typeface="Arial"/>
-                <a:cs typeface="Arial"/>
-              </a:defRPr>
-            </a:pPr>
-            <a:r>
-              <a:rPr sz="1200" b="1" i="0">
-                <a:solidFill>
-                  <a:srgbClr val="002855"/>
-                </a:solidFill>
-                <a:latin typeface="Arial"/>
-                <a:ea typeface="Arial"/>
-                <a:cs typeface="Arial"/>
-              </a:rPr>
-              <a:t>WVU DSPIRA</a:t>
-            </a:r>
-          </a:p>
-        </p:txBody>
-      </p:sp>
-      <p:sp>
-        <p:nvSpPr>
           <p:cNvPr id="7" name="">
             <a:extLst xmlns:a="http://schemas.openxmlformats.org/drawingml/2006/main">
               <a:ext uri="{FF2B5EF4-FFF2-40B4-BE49-F238E27FC236}">
@@ -4276,6 +4571,156 @@
                 <a:cs typeface="Arial"/>
               </a:rPr>
               <a:t>5 of 8</a:t>
+            </a:r>
+          </a:p>
+        </p:txBody>
+      </p:sp>
+      <p:sp>
+        <p:nvSpPr>
+          <p:cNvPr id="10" name="WVU DSPIRA navy band"/>
+          <p:cNvSpPr>
+            <a:spLocks xmlns:a="http://schemas.openxmlformats.org/drawingml/2006/main" noGrp="1"/>
+          </p:cNvSpPr>
+          <p:nvPr/>
+        </p:nvSpPr>
+        <p:spPr>
+          <a:xfrm xmlns:a="http://schemas.openxmlformats.org/drawingml/2006/main">
+            <a:off x="0" y="0"/>
+            <a:ext cx="9144000" cy="323850"/>
+          </a:xfrm>
+          <a:prstGeom xmlns:a="http://schemas.openxmlformats.org/drawingml/2006/main" prst="rect">
+            <a:avLst/>
+          </a:prstGeom>
+          <a:solidFill xmlns:a="http://schemas.openxmlformats.org/drawingml/2006/main">
+            <a:srgbClr val="002855"/>
+          </a:solidFill>
+          <a:ln xmlns:a="http://schemas.openxmlformats.org/drawingml/2006/main" w="0">
+            <a:noFill/>
+          </a:ln>
+        </p:spPr>
+      </p:sp>
+      <p:sp>
+        <p:nvSpPr>
+          <p:cNvPr id="11" name="WVU DSPIRA gold rule"/>
+          <p:cNvSpPr>
+            <a:spLocks xmlns:a="http://schemas.openxmlformats.org/drawingml/2006/main" noGrp="1"/>
+          </p:cNvSpPr>
+          <p:nvPr/>
+        </p:nvSpPr>
+        <p:spPr>
+          <a:xfrm xmlns:a="http://schemas.openxmlformats.org/drawingml/2006/main">
+            <a:off x="0" y="323850"/>
+            <a:ext cx="9144000" cy="19050"/>
+          </a:xfrm>
+          <a:prstGeom xmlns:a="http://schemas.openxmlformats.org/drawingml/2006/main" prst="rect">
+            <a:avLst/>
+          </a:prstGeom>
+          <a:solidFill xmlns:a="http://schemas.openxmlformats.org/drawingml/2006/main">
+            <a:srgbClr val="EEAA00"/>
+          </a:solidFill>
+          <a:ln xmlns:a="http://schemas.openxmlformats.org/drawingml/2006/main" w="0">
+            <a:noFill/>
+          </a:ln>
+        </p:spPr>
+      </p:sp>
+      <p:sp>
+        <p:nvSpPr>
+          <p:cNvPr id="12" name="WVU DSPIRA name"/>
+          <p:cNvSpPr>
+            <a:spLocks xmlns:a="http://schemas.openxmlformats.org/drawingml/2006/main" noGrp="1"/>
+          </p:cNvSpPr>
+          <p:nvPr/>
+        </p:nvSpPr>
+        <p:spPr>
+          <a:xfrm xmlns:a="http://schemas.openxmlformats.org/drawingml/2006/main">
+            <a:off x="228600" y="19050"/>
+            <a:ext cx="2857500" cy="257175"/>
+          </a:xfrm>
+          <a:prstGeom xmlns:a="http://schemas.openxmlformats.org/drawingml/2006/main" prst="rect">
+            <a:avLst/>
+          </a:prstGeom>
+          <a:noFill xmlns:a="http://schemas.openxmlformats.org/drawingml/2006/main"/>
+          <a:ln xmlns:a="http://schemas.openxmlformats.org/drawingml/2006/main" w="0">
+            <a:noFill/>
+          </a:ln>
+        </p:spPr>
+        <p:txBody>
+          <a:bodyPr xmlns:a="http://schemas.openxmlformats.org/drawingml/2006/main">
+            <a:noAutofit/>
+          </a:bodyPr>
+          <a:lstStyle xmlns:a="http://schemas.openxmlformats.org/drawingml/2006/main"/>
+          <a:p xmlns:a="http://schemas.openxmlformats.org/drawingml/2006/main">
+            <a:pPr>
+              <a:defRPr sz="1600" b="1">
+                <a:solidFill>
+                  <a:srgbClr val="FFFFFF"/>
+                </a:solidFill>
+                <a:latin typeface="Arial"/>
+                <a:ea typeface="Arial"/>
+                <a:cs typeface="Arial"/>
+              </a:defRPr>
+            </a:pPr>
+            <a:r>
+              <a:rPr sz="1600" b="1">
+                <a:solidFill>
+                  <a:srgbClr val="FFFFFF"/>
+                </a:solidFill>
+                <a:latin typeface="Arial"/>
+                <a:ea typeface="Arial"/>
+                <a:cs typeface="Arial"/>
+              </a:rPr>
+              <a:t>WVU DSPIRA</a:t>
+            </a:r>
+          </a:p>
+        </p:txBody>
+      </p:sp>
+      <p:sp>
+        <p:nvSpPr>
+          <p:cNvPr id="13" name="WVU DSPIRA university"/>
+          <p:cNvSpPr>
+            <a:spLocks xmlns:a="http://schemas.openxmlformats.org/drawingml/2006/main" noGrp="1"/>
+          </p:cNvSpPr>
+          <p:nvPr/>
+        </p:nvSpPr>
+        <p:spPr>
+          <a:xfrm xmlns:a="http://schemas.openxmlformats.org/drawingml/2006/main">
+            <a:off x="6286500" y="114300"/>
+            <a:ext cx="2628900" cy="171450"/>
+          </a:xfrm>
+          <a:prstGeom xmlns:a="http://schemas.openxmlformats.org/drawingml/2006/main" prst="rect">
+            <a:avLst/>
+          </a:prstGeom>
+          <a:noFill xmlns:a="http://schemas.openxmlformats.org/drawingml/2006/main"/>
+          <a:ln xmlns:a="http://schemas.openxmlformats.org/drawingml/2006/main" w="0">
+            <a:noFill/>
+          </a:ln>
+        </p:spPr>
+        <p:txBody>
+          <a:bodyPr xmlns:a="http://schemas.openxmlformats.org/drawingml/2006/main">
+            <a:noAutofit/>
+          </a:bodyPr>
+          <a:lstStyle xmlns:a="http://schemas.openxmlformats.org/drawingml/2006/main"/>
+          <a:p xmlns:a="http://schemas.openxmlformats.org/drawingml/2006/main">
+            <a:pPr algn="r">
+              <a:defRPr sz="900">
+                <a:solidFill>
+                  <a:srgbClr val="FFFFFF"/>
+                </a:solidFill>
+                <a:latin typeface="Arial"/>
+                <a:ea typeface="Arial"/>
+                <a:cs typeface="Arial"/>
+              </a:defRPr>
+            </a:pPr>
+            <a:r>
+              <a:rPr sz="900">
+                <a:solidFill>
+                  <a:srgbClr val="FFFFFF"/>
+                </a:solidFill>
+                <a:latin typeface="Arial"/>
+                <a:ea typeface="Arial"/>
+                <a:cs typeface="Arial"/>
+              </a:rPr>
+              <a:t>WEST VIRGINIA UNIVERSITY</a:t>
             </a:r>
           </a:p>
         </p:txBody>
@@ -4882,67 +5327,6 @@
       </p:sp>
       <p:sp>
         <p:nvSpPr>
-          <p:cNvPr id="11" name="">
-            <a:extLst xmlns:a="http://schemas.openxmlformats.org/drawingml/2006/main">
-              <a:ext uri="{FF2B5EF4-FFF2-40B4-BE49-F238E27FC236}">
-                <a16:creationId xmlns:a16="http://schemas.microsoft.com/office/drawing/2014/main" id="{26814A5C-ACE0-4B39-91D4-8F664F9DED86}"/>
-              </a:ext>
-            </a:extLst>
-          </p:cNvPr>
-          <p:cNvSpPr>
-            <a:spLocks xmlns:a="http://schemas.openxmlformats.org/drawingml/2006/main" noGrp="1"/>
-          </p:cNvSpPr>
-          <p:nvPr/>
-        </p:nvSpPr>
-        <p:spPr>
-          <a:xfrm xmlns:a="http://schemas.openxmlformats.org/drawingml/2006/main">
-            <a:off x="228600" y="76200"/>
-            <a:ext cx="8686800" cy="228600"/>
-          </a:xfrm>
-          <a:prstGeom xmlns:a="http://schemas.openxmlformats.org/drawingml/2006/main" prst="rect">
-            <a:avLst/>
-          </a:prstGeom>
-          <a:noFill xmlns:a="http://schemas.openxmlformats.org/drawingml/2006/main"/>
-          <a:ln xmlns:a="http://schemas.openxmlformats.org/drawingml/2006/main" w="0">
-            <a:noFill/>
-          </a:ln>
-        </p:spPr>
-        <p:txBody>
-          <a:bodyPr xmlns:a="http://schemas.openxmlformats.org/drawingml/2006/main" wrap="none" lIns="0" tIns="0" rIns="0" bIns="0" anchor="t">
-            <a:noAutofit/>
-          </a:bodyPr>
-          <a:lstStyle xmlns:a="http://schemas.openxmlformats.org/drawingml/2006/main"/>
-          <a:p xmlns:a="http://schemas.openxmlformats.org/drawingml/2006/main">
-            <a:pPr>
-              <a:lnSpc>
-                <a:spcPct val="100000"/>
-              </a:lnSpc>
-              <a:buNone/>
-              <a:defRPr sz="1200" b="1" i="0">
-                <a:solidFill>
-                  <a:srgbClr val="002855"/>
-                </a:solidFill>
-                <a:latin typeface="Arial"/>
-                <a:ea typeface="Arial"/>
-                <a:cs typeface="Arial"/>
-              </a:defRPr>
-            </a:pPr>
-            <a:r>
-              <a:rPr sz="1200" b="1" i="0">
-                <a:solidFill>
-                  <a:srgbClr val="002855"/>
-                </a:solidFill>
-                <a:latin typeface="Arial"/>
-                <a:ea typeface="Arial"/>
-                <a:cs typeface="Arial"/>
-              </a:rPr>
-              <a:t>WVU DSPIRA</a:t>
-            </a:r>
-          </a:p>
-        </p:txBody>
-      </p:sp>
-      <p:sp>
-        <p:nvSpPr>
           <p:cNvPr id="12" name="">
             <a:extLst xmlns:a="http://schemas.openxmlformats.org/drawingml/2006/main">
               <a:ext uri="{FF2B5EF4-FFF2-40B4-BE49-F238E27FC236}">
@@ -5059,6 +5443,156 @@
                 <a:cs typeface="Arial"/>
               </a:rPr>
               <a:t>6 of 8</a:t>
+            </a:r>
+          </a:p>
+        </p:txBody>
+      </p:sp>
+      <p:sp>
+        <p:nvSpPr>
+          <p:cNvPr id="15" name="WVU DSPIRA navy band"/>
+          <p:cNvSpPr>
+            <a:spLocks xmlns:a="http://schemas.openxmlformats.org/drawingml/2006/main" noGrp="1"/>
+          </p:cNvSpPr>
+          <p:nvPr/>
+        </p:nvSpPr>
+        <p:spPr>
+          <a:xfrm xmlns:a="http://schemas.openxmlformats.org/drawingml/2006/main">
+            <a:off x="0" y="0"/>
+            <a:ext cx="9144000" cy="323850"/>
+          </a:xfrm>
+          <a:prstGeom xmlns:a="http://schemas.openxmlformats.org/drawingml/2006/main" prst="rect">
+            <a:avLst/>
+          </a:prstGeom>
+          <a:solidFill xmlns:a="http://schemas.openxmlformats.org/drawingml/2006/main">
+            <a:srgbClr val="002855"/>
+          </a:solidFill>
+          <a:ln xmlns:a="http://schemas.openxmlformats.org/drawingml/2006/main" w="0">
+            <a:noFill/>
+          </a:ln>
+        </p:spPr>
+      </p:sp>
+      <p:sp>
+        <p:nvSpPr>
+          <p:cNvPr id="16" name="WVU DSPIRA gold rule"/>
+          <p:cNvSpPr>
+            <a:spLocks xmlns:a="http://schemas.openxmlformats.org/drawingml/2006/main" noGrp="1"/>
+          </p:cNvSpPr>
+          <p:nvPr/>
+        </p:nvSpPr>
+        <p:spPr>
+          <a:xfrm xmlns:a="http://schemas.openxmlformats.org/drawingml/2006/main">
+            <a:off x="0" y="323850"/>
+            <a:ext cx="9144000" cy="19050"/>
+          </a:xfrm>
+          <a:prstGeom xmlns:a="http://schemas.openxmlformats.org/drawingml/2006/main" prst="rect">
+            <a:avLst/>
+          </a:prstGeom>
+          <a:solidFill xmlns:a="http://schemas.openxmlformats.org/drawingml/2006/main">
+            <a:srgbClr val="EEAA00"/>
+          </a:solidFill>
+          <a:ln xmlns:a="http://schemas.openxmlformats.org/drawingml/2006/main" w="0">
+            <a:noFill/>
+          </a:ln>
+        </p:spPr>
+      </p:sp>
+      <p:sp>
+        <p:nvSpPr>
+          <p:cNvPr id="17" name="WVU DSPIRA name"/>
+          <p:cNvSpPr>
+            <a:spLocks xmlns:a="http://schemas.openxmlformats.org/drawingml/2006/main" noGrp="1"/>
+          </p:cNvSpPr>
+          <p:nvPr/>
+        </p:nvSpPr>
+        <p:spPr>
+          <a:xfrm xmlns:a="http://schemas.openxmlformats.org/drawingml/2006/main">
+            <a:off x="228600" y="19050"/>
+            <a:ext cx="2857500" cy="257175"/>
+          </a:xfrm>
+          <a:prstGeom xmlns:a="http://schemas.openxmlformats.org/drawingml/2006/main" prst="rect">
+            <a:avLst/>
+          </a:prstGeom>
+          <a:noFill xmlns:a="http://schemas.openxmlformats.org/drawingml/2006/main"/>
+          <a:ln xmlns:a="http://schemas.openxmlformats.org/drawingml/2006/main" w="0">
+            <a:noFill/>
+          </a:ln>
+        </p:spPr>
+        <p:txBody>
+          <a:bodyPr xmlns:a="http://schemas.openxmlformats.org/drawingml/2006/main">
+            <a:noAutofit/>
+          </a:bodyPr>
+          <a:lstStyle xmlns:a="http://schemas.openxmlformats.org/drawingml/2006/main"/>
+          <a:p xmlns:a="http://schemas.openxmlformats.org/drawingml/2006/main">
+            <a:pPr>
+              <a:defRPr sz="1600" b="1">
+                <a:solidFill>
+                  <a:srgbClr val="FFFFFF"/>
+                </a:solidFill>
+                <a:latin typeface="Arial"/>
+                <a:ea typeface="Arial"/>
+                <a:cs typeface="Arial"/>
+              </a:defRPr>
+            </a:pPr>
+            <a:r>
+              <a:rPr sz="1600" b="1">
+                <a:solidFill>
+                  <a:srgbClr val="FFFFFF"/>
+                </a:solidFill>
+                <a:latin typeface="Arial"/>
+                <a:ea typeface="Arial"/>
+                <a:cs typeface="Arial"/>
+              </a:rPr>
+              <a:t>WVU DSPIRA</a:t>
+            </a:r>
+          </a:p>
+        </p:txBody>
+      </p:sp>
+      <p:sp>
+        <p:nvSpPr>
+          <p:cNvPr id="18" name="WVU DSPIRA university"/>
+          <p:cNvSpPr>
+            <a:spLocks xmlns:a="http://schemas.openxmlformats.org/drawingml/2006/main" noGrp="1"/>
+          </p:cNvSpPr>
+          <p:nvPr/>
+        </p:nvSpPr>
+        <p:spPr>
+          <a:xfrm xmlns:a="http://schemas.openxmlformats.org/drawingml/2006/main">
+            <a:off x="6286500" y="114300"/>
+            <a:ext cx="2628900" cy="171450"/>
+          </a:xfrm>
+          <a:prstGeom xmlns:a="http://schemas.openxmlformats.org/drawingml/2006/main" prst="rect">
+            <a:avLst/>
+          </a:prstGeom>
+          <a:noFill xmlns:a="http://schemas.openxmlformats.org/drawingml/2006/main"/>
+          <a:ln xmlns:a="http://schemas.openxmlformats.org/drawingml/2006/main" w="0">
+            <a:noFill/>
+          </a:ln>
+        </p:spPr>
+        <p:txBody>
+          <a:bodyPr xmlns:a="http://schemas.openxmlformats.org/drawingml/2006/main">
+            <a:noAutofit/>
+          </a:bodyPr>
+          <a:lstStyle xmlns:a="http://schemas.openxmlformats.org/drawingml/2006/main"/>
+          <a:p xmlns:a="http://schemas.openxmlformats.org/drawingml/2006/main">
+            <a:pPr algn="r">
+              <a:defRPr sz="900">
+                <a:solidFill>
+                  <a:srgbClr val="FFFFFF"/>
+                </a:solidFill>
+                <a:latin typeface="Arial"/>
+                <a:ea typeface="Arial"/>
+                <a:cs typeface="Arial"/>
+              </a:defRPr>
+            </a:pPr>
+            <a:r>
+              <a:rPr sz="900">
+                <a:solidFill>
+                  <a:srgbClr val="FFFFFF"/>
+                </a:solidFill>
+                <a:latin typeface="Arial"/>
+                <a:ea typeface="Arial"/>
+                <a:cs typeface="Arial"/>
+              </a:rPr>
+              <a:t>WEST VIRGINIA UNIVERSITY</a:t>
             </a:r>
           </a:p>
         </p:txBody>
@@ -5970,67 +6504,6 @@
       </p:sp>
       <p:sp>
         <p:nvSpPr>
-          <p:cNvPr id="16" name="">
-            <a:extLst xmlns:a="http://schemas.openxmlformats.org/drawingml/2006/main">
-              <a:ext uri="{FF2B5EF4-FFF2-40B4-BE49-F238E27FC236}">
-                <a16:creationId xmlns:a16="http://schemas.microsoft.com/office/drawing/2014/main" id="{7FB65DA2-48EC-4CE3-8B5C-8932974AC64D}"/>
-              </a:ext>
-            </a:extLst>
-          </p:cNvPr>
-          <p:cNvSpPr>
-            <a:spLocks xmlns:a="http://schemas.openxmlformats.org/drawingml/2006/main" noGrp="1"/>
-          </p:cNvSpPr>
-          <p:nvPr/>
-        </p:nvSpPr>
-        <p:spPr>
-          <a:xfrm xmlns:a="http://schemas.openxmlformats.org/drawingml/2006/main">
-            <a:off x="228600" y="76200"/>
-            <a:ext cx="8686800" cy="228600"/>
-          </a:xfrm>
-          <a:prstGeom xmlns:a="http://schemas.openxmlformats.org/drawingml/2006/main" prst="rect">
-            <a:avLst/>
-          </a:prstGeom>
-          <a:noFill xmlns:a="http://schemas.openxmlformats.org/drawingml/2006/main"/>
-          <a:ln xmlns:a="http://schemas.openxmlformats.org/drawingml/2006/main" w="0">
-            <a:noFill/>
-          </a:ln>
-        </p:spPr>
-        <p:txBody>
-          <a:bodyPr xmlns:a="http://schemas.openxmlformats.org/drawingml/2006/main" wrap="none" lIns="0" tIns="0" rIns="0" bIns="0" anchor="t">
-            <a:noAutofit/>
-          </a:bodyPr>
-          <a:lstStyle xmlns:a="http://schemas.openxmlformats.org/drawingml/2006/main"/>
-          <a:p xmlns:a="http://schemas.openxmlformats.org/drawingml/2006/main">
-            <a:pPr>
-              <a:lnSpc>
-                <a:spcPct val="100000"/>
-              </a:lnSpc>
-              <a:buNone/>
-              <a:defRPr sz="1200" b="1" i="0">
-                <a:solidFill>
-                  <a:srgbClr val="002855"/>
-                </a:solidFill>
-                <a:latin typeface="Arial"/>
-                <a:ea typeface="Arial"/>
-                <a:cs typeface="Arial"/>
-              </a:defRPr>
-            </a:pPr>
-            <a:r>
-              <a:rPr sz="1200" b="1" i="0">
-                <a:solidFill>
-                  <a:srgbClr val="002855"/>
-                </a:solidFill>
-                <a:latin typeface="Arial"/>
-                <a:ea typeface="Arial"/>
-                <a:cs typeface="Arial"/>
-              </a:rPr>
-              <a:t>WVU DSPIRA</a:t>
-            </a:r>
-          </a:p>
-        </p:txBody>
-      </p:sp>
-      <p:sp>
-        <p:nvSpPr>
           <p:cNvPr id="17" name="">
             <a:extLst xmlns:a="http://schemas.openxmlformats.org/drawingml/2006/main">
               <a:ext uri="{FF2B5EF4-FFF2-40B4-BE49-F238E27FC236}">
@@ -6147,6 +6620,156 @@
                 <a:cs typeface="Arial"/>
               </a:rPr>
               <a:t>7 of 8</a:t>
+            </a:r>
+          </a:p>
+        </p:txBody>
+      </p:sp>
+      <p:sp>
+        <p:nvSpPr>
+          <p:cNvPr id="20" name="WVU DSPIRA navy band"/>
+          <p:cNvSpPr>
+            <a:spLocks xmlns:a="http://schemas.openxmlformats.org/drawingml/2006/main" noGrp="1"/>
+          </p:cNvSpPr>
+          <p:nvPr/>
+        </p:nvSpPr>
+        <p:spPr>
+          <a:xfrm xmlns:a="http://schemas.openxmlformats.org/drawingml/2006/main">
+            <a:off x="0" y="0"/>
+            <a:ext cx="9144000" cy="323850"/>
+          </a:xfrm>
+          <a:prstGeom xmlns:a="http://schemas.openxmlformats.org/drawingml/2006/main" prst="rect">
+            <a:avLst/>
+          </a:prstGeom>
+          <a:solidFill xmlns:a="http://schemas.openxmlformats.org/drawingml/2006/main">
+            <a:srgbClr val="002855"/>
+          </a:solidFill>
+          <a:ln xmlns:a="http://schemas.openxmlformats.org/drawingml/2006/main" w="0">
+            <a:noFill/>
+          </a:ln>
+        </p:spPr>
+      </p:sp>
+      <p:sp>
+        <p:nvSpPr>
+          <p:cNvPr id="21" name="WVU DSPIRA gold rule"/>
+          <p:cNvSpPr>
+            <a:spLocks xmlns:a="http://schemas.openxmlformats.org/drawingml/2006/main" noGrp="1"/>
+          </p:cNvSpPr>
+          <p:nvPr/>
+        </p:nvSpPr>
+        <p:spPr>
+          <a:xfrm xmlns:a="http://schemas.openxmlformats.org/drawingml/2006/main">
+            <a:off x="0" y="323850"/>
+            <a:ext cx="9144000" cy="19050"/>
+          </a:xfrm>
+          <a:prstGeom xmlns:a="http://schemas.openxmlformats.org/drawingml/2006/main" prst="rect">
+            <a:avLst/>
+          </a:prstGeom>
+          <a:solidFill xmlns:a="http://schemas.openxmlformats.org/drawingml/2006/main">
+            <a:srgbClr val="EEAA00"/>
+          </a:solidFill>
+          <a:ln xmlns:a="http://schemas.openxmlformats.org/drawingml/2006/main" w="0">
+            <a:noFill/>
+          </a:ln>
+        </p:spPr>
+      </p:sp>
+      <p:sp>
+        <p:nvSpPr>
+          <p:cNvPr id="22" name="WVU DSPIRA name"/>
+          <p:cNvSpPr>
+            <a:spLocks xmlns:a="http://schemas.openxmlformats.org/drawingml/2006/main" noGrp="1"/>
+          </p:cNvSpPr>
+          <p:nvPr/>
+        </p:nvSpPr>
+        <p:spPr>
+          <a:xfrm xmlns:a="http://schemas.openxmlformats.org/drawingml/2006/main">
+            <a:off x="228600" y="19050"/>
+            <a:ext cx="2857500" cy="257175"/>
+          </a:xfrm>
+          <a:prstGeom xmlns:a="http://schemas.openxmlformats.org/drawingml/2006/main" prst="rect">
+            <a:avLst/>
+          </a:prstGeom>
+          <a:noFill xmlns:a="http://schemas.openxmlformats.org/drawingml/2006/main"/>
+          <a:ln xmlns:a="http://schemas.openxmlformats.org/drawingml/2006/main" w="0">
+            <a:noFill/>
+          </a:ln>
+        </p:spPr>
+        <p:txBody>
+          <a:bodyPr xmlns:a="http://schemas.openxmlformats.org/drawingml/2006/main">
+            <a:noAutofit/>
+          </a:bodyPr>
+          <a:lstStyle xmlns:a="http://schemas.openxmlformats.org/drawingml/2006/main"/>
+          <a:p xmlns:a="http://schemas.openxmlformats.org/drawingml/2006/main">
+            <a:pPr>
+              <a:defRPr sz="1600" b="1">
+                <a:solidFill>
+                  <a:srgbClr val="FFFFFF"/>
+                </a:solidFill>
+                <a:latin typeface="Arial"/>
+                <a:ea typeface="Arial"/>
+                <a:cs typeface="Arial"/>
+              </a:defRPr>
+            </a:pPr>
+            <a:r>
+              <a:rPr sz="1600" b="1">
+                <a:solidFill>
+                  <a:srgbClr val="FFFFFF"/>
+                </a:solidFill>
+                <a:latin typeface="Arial"/>
+                <a:ea typeface="Arial"/>
+                <a:cs typeface="Arial"/>
+              </a:rPr>
+              <a:t>WVU DSPIRA</a:t>
+            </a:r>
+          </a:p>
+        </p:txBody>
+      </p:sp>
+      <p:sp>
+        <p:nvSpPr>
+          <p:cNvPr id="23" name="WVU DSPIRA university"/>
+          <p:cNvSpPr>
+            <a:spLocks xmlns:a="http://schemas.openxmlformats.org/drawingml/2006/main" noGrp="1"/>
+          </p:cNvSpPr>
+          <p:nvPr/>
+        </p:nvSpPr>
+        <p:spPr>
+          <a:xfrm xmlns:a="http://schemas.openxmlformats.org/drawingml/2006/main">
+            <a:off x="6286500" y="114300"/>
+            <a:ext cx="2628900" cy="171450"/>
+          </a:xfrm>
+          <a:prstGeom xmlns:a="http://schemas.openxmlformats.org/drawingml/2006/main" prst="rect">
+            <a:avLst/>
+          </a:prstGeom>
+          <a:noFill xmlns:a="http://schemas.openxmlformats.org/drawingml/2006/main"/>
+          <a:ln xmlns:a="http://schemas.openxmlformats.org/drawingml/2006/main" w="0">
+            <a:noFill/>
+          </a:ln>
+        </p:spPr>
+        <p:txBody>
+          <a:bodyPr xmlns:a="http://schemas.openxmlformats.org/drawingml/2006/main">
+            <a:noAutofit/>
+          </a:bodyPr>
+          <a:lstStyle xmlns:a="http://schemas.openxmlformats.org/drawingml/2006/main"/>
+          <a:p xmlns:a="http://schemas.openxmlformats.org/drawingml/2006/main">
+            <a:pPr algn="r">
+              <a:defRPr sz="900">
+                <a:solidFill>
+                  <a:srgbClr val="FFFFFF"/>
+                </a:solidFill>
+                <a:latin typeface="Arial"/>
+                <a:ea typeface="Arial"/>
+                <a:cs typeface="Arial"/>
+              </a:defRPr>
+            </a:pPr>
+            <a:r>
+              <a:rPr sz="900">
+                <a:solidFill>
+                  <a:srgbClr val="FFFFFF"/>
+                </a:solidFill>
+                <a:latin typeface="Arial"/>
+                <a:ea typeface="Arial"/>
+                <a:cs typeface="Arial"/>
+              </a:rPr>
+              <a:t>WEST VIRGINIA UNIVERSITY</a:t>
             </a:r>
           </a:p>
         </p:txBody>
@@ -7363,67 +7986,6 @@
       </p:sp>
       <p:sp>
         <p:nvSpPr>
-          <p:cNvPr id="21" name="">
-            <a:extLst xmlns:a="http://schemas.openxmlformats.org/drawingml/2006/main">
-              <a:ext uri="{FF2B5EF4-FFF2-40B4-BE49-F238E27FC236}">
-                <a16:creationId xmlns:a16="http://schemas.microsoft.com/office/drawing/2014/main" id="{F851EAB6-3019-4740-B0BC-5B7C741F6F9D}"/>
-              </a:ext>
-            </a:extLst>
-          </p:cNvPr>
-          <p:cNvSpPr>
-            <a:spLocks xmlns:a="http://schemas.openxmlformats.org/drawingml/2006/main" noGrp="1"/>
-          </p:cNvSpPr>
-          <p:nvPr/>
-        </p:nvSpPr>
-        <p:spPr>
-          <a:xfrm xmlns:a="http://schemas.openxmlformats.org/drawingml/2006/main">
-            <a:off x="228600" y="76200"/>
-            <a:ext cx="8686800" cy="228600"/>
-          </a:xfrm>
-          <a:prstGeom xmlns:a="http://schemas.openxmlformats.org/drawingml/2006/main" prst="rect">
-            <a:avLst/>
-          </a:prstGeom>
-          <a:noFill xmlns:a="http://schemas.openxmlformats.org/drawingml/2006/main"/>
-          <a:ln xmlns:a="http://schemas.openxmlformats.org/drawingml/2006/main" w="0">
-            <a:noFill/>
-          </a:ln>
-        </p:spPr>
-        <p:txBody>
-          <a:bodyPr xmlns:a="http://schemas.openxmlformats.org/drawingml/2006/main" wrap="none" lIns="0" tIns="0" rIns="0" bIns="0" anchor="t">
-            <a:noAutofit/>
-          </a:bodyPr>
-          <a:lstStyle xmlns:a="http://schemas.openxmlformats.org/drawingml/2006/main"/>
-          <a:p xmlns:a="http://schemas.openxmlformats.org/drawingml/2006/main">
-            <a:pPr>
-              <a:lnSpc>
-                <a:spcPct val="100000"/>
-              </a:lnSpc>
-              <a:buNone/>
-              <a:defRPr sz="1200" b="1" i="0">
-                <a:solidFill>
-                  <a:srgbClr val="002855"/>
-                </a:solidFill>
-                <a:latin typeface="Arial"/>
-                <a:ea typeface="Arial"/>
-                <a:cs typeface="Arial"/>
-              </a:defRPr>
-            </a:pPr>
-            <a:r>
-              <a:rPr sz="1200" b="1" i="0">
-                <a:solidFill>
-                  <a:srgbClr val="002855"/>
-                </a:solidFill>
-                <a:latin typeface="Arial"/>
-                <a:ea typeface="Arial"/>
-                <a:cs typeface="Arial"/>
-              </a:rPr>
-              <a:t>WVU DSPIRA</a:t>
-            </a:r>
-          </a:p>
-        </p:txBody>
-      </p:sp>
-      <p:sp>
-        <p:nvSpPr>
           <p:cNvPr id="22" name="">
             <a:extLst xmlns:a="http://schemas.openxmlformats.org/drawingml/2006/main">
               <a:ext uri="{FF2B5EF4-FFF2-40B4-BE49-F238E27FC236}">
@@ -7627,6 +8189,156 @@
             <a:noFill/>
           </a:ln>
         </p:spPr>
+      </p:sp>
+      <p:sp>
+        <p:nvSpPr>
+          <p:cNvPr id="28" name="WVU DSPIRA navy band"/>
+          <p:cNvSpPr>
+            <a:spLocks xmlns:a="http://schemas.openxmlformats.org/drawingml/2006/main" noGrp="1"/>
+          </p:cNvSpPr>
+          <p:nvPr/>
+        </p:nvSpPr>
+        <p:spPr>
+          <a:xfrm xmlns:a="http://schemas.openxmlformats.org/drawingml/2006/main">
+            <a:off x="0" y="0"/>
+            <a:ext cx="9144000" cy="323850"/>
+          </a:xfrm>
+          <a:prstGeom xmlns:a="http://schemas.openxmlformats.org/drawingml/2006/main" prst="rect">
+            <a:avLst/>
+          </a:prstGeom>
+          <a:solidFill xmlns:a="http://schemas.openxmlformats.org/drawingml/2006/main">
+            <a:srgbClr val="002855"/>
+          </a:solidFill>
+          <a:ln xmlns:a="http://schemas.openxmlformats.org/drawingml/2006/main" w="0">
+            <a:noFill/>
+          </a:ln>
+        </p:spPr>
+      </p:sp>
+      <p:sp>
+        <p:nvSpPr>
+          <p:cNvPr id="29" name="WVU DSPIRA gold rule"/>
+          <p:cNvSpPr>
+            <a:spLocks xmlns:a="http://schemas.openxmlformats.org/drawingml/2006/main" noGrp="1"/>
+          </p:cNvSpPr>
+          <p:nvPr/>
+        </p:nvSpPr>
+        <p:spPr>
+          <a:xfrm xmlns:a="http://schemas.openxmlformats.org/drawingml/2006/main">
+            <a:off x="0" y="323850"/>
+            <a:ext cx="9144000" cy="19050"/>
+          </a:xfrm>
+          <a:prstGeom xmlns:a="http://schemas.openxmlformats.org/drawingml/2006/main" prst="rect">
+            <a:avLst/>
+          </a:prstGeom>
+          <a:solidFill xmlns:a="http://schemas.openxmlformats.org/drawingml/2006/main">
+            <a:srgbClr val="EEAA00"/>
+          </a:solidFill>
+          <a:ln xmlns:a="http://schemas.openxmlformats.org/drawingml/2006/main" w="0">
+            <a:noFill/>
+          </a:ln>
+        </p:spPr>
+      </p:sp>
+      <p:sp>
+        <p:nvSpPr>
+          <p:cNvPr id="30" name="WVU DSPIRA name"/>
+          <p:cNvSpPr>
+            <a:spLocks xmlns:a="http://schemas.openxmlformats.org/drawingml/2006/main" noGrp="1"/>
+          </p:cNvSpPr>
+          <p:nvPr/>
+        </p:nvSpPr>
+        <p:spPr>
+          <a:xfrm xmlns:a="http://schemas.openxmlformats.org/drawingml/2006/main">
+            <a:off x="228600" y="19050"/>
+            <a:ext cx="2857500" cy="257175"/>
+          </a:xfrm>
+          <a:prstGeom xmlns:a="http://schemas.openxmlformats.org/drawingml/2006/main" prst="rect">
+            <a:avLst/>
+          </a:prstGeom>
+          <a:noFill xmlns:a="http://schemas.openxmlformats.org/drawingml/2006/main"/>
+          <a:ln xmlns:a="http://schemas.openxmlformats.org/drawingml/2006/main" w="0">
+            <a:noFill/>
+          </a:ln>
+        </p:spPr>
+        <p:txBody>
+          <a:bodyPr xmlns:a="http://schemas.openxmlformats.org/drawingml/2006/main">
+            <a:noAutofit/>
+          </a:bodyPr>
+          <a:lstStyle xmlns:a="http://schemas.openxmlformats.org/drawingml/2006/main"/>
+          <a:p xmlns:a="http://schemas.openxmlformats.org/drawingml/2006/main">
+            <a:pPr>
+              <a:defRPr sz="1600" b="1">
+                <a:solidFill>
+                  <a:srgbClr val="FFFFFF"/>
+                </a:solidFill>
+                <a:latin typeface="Arial"/>
+                <a:ea typeface="Arial"/>
+                <a:cs typeface="Arial"/>
+              </a:defRPr>
+            </a:pPr>
+            <a:r>
+              <a:rPr sz="1600" b="1">
+                <a:solidFill>
+                  <a:srgbClr val="FFFFFF"/>
+                </a:solidFill>
+                <a:latin typeface="Arial"/>
+                <a:ea typeface="Arial"/>
+                <a:cs typeface="Arial"/>
+              </a:rPr>
+              <a:t>WVU DSPIRA</a:t>
+            </a:r>
+          </a:p>
+        </p:txBody>
+      </p:sp>
+      <p:sp>
+        <p:nvSpPr>
+          <p:cNvPr id="31" name="WVU DSPIRA university"/>
+          <p:cNvSpPr>
+            <a:spLocks xmlns:a="http://schemas.openxmlformats.org/drawingml/2006/main" noGrp="1"/>
+          </p:cNvSpPr>
+          <p:nvPr/>
+        </p:nvSpPr>
+        <p:spPr>
+          <a:xfrm xmlns:a="http://schemas.openxmlformats.org/drawingml/2006/main">
+            <a:off x="6286500" y="114300"/>
+            <a:ext cx="2628900" cy="171450"/>
+          </a:xfrm>
+          <a:prstGeom xmlns:a="http://schemas.openxmlformats.org/drawingml/2006/main" prst="rect">
+            <a:avLst/>
+          </a:prstGeom>
+          <a:noFill xmlns:a="http://schemas.openxmlformats.org/drawingml/2006/main"/>
+          <a:ln xmlns:a="http://schemas.openxmlformats.org/drawingml/2006/main" w="0">
+            <a:noFill/>
+          </a:ln>
+        </p:spPr>
+        <p:txBody>
+          <a:bodyPr xmlns:a="http://schemas.openxmlformats.org/drawingml/2006/main">
+            <a:noAutofit/>
+          </a:bodyPr>
+          <a:lstStyle xmlns:a="http://schemas.openxmlformats.org/drawingml/2006/main"/>
+          <a:p xmlns:a="http://schemas.openxmlformats.org/drawingml/2006/main">
+            <a:pPr algn="r">
+              <a:defRPr sz="900">
+                <a:solidFill>
+                  <a:srgbClr val="FFFFFF"/>
+                </a:solidFill>
+                <a:latin typeface="Arial"/>
+                <a:ea typeface="Arial"/>
+                <a:cs typeface="Arial"/>
+              </a:defRPr>
+            </a:pPr>
+            <a:r>
+              <a:rPr sz="900">
+                <a:solidFill>
+                  <a:srgbClr val="FFFFFF"/>
+                </a:solidFill>
+                <a:latin typeface="Arial"/>
+                <a:ea typeface="Arial"/>
+                <a:cs typeface="Arial"/>
+              </a:rPr>
+              <a:t>WEST VIRGINIA UNIVERSITY</a:t>
+            </a:r>
+          </a:p>
+        </p:txBody>
       </p:sp>
     </p:spTree>
     <p:extLst>

</xml_diff>